<commit_message>
cierre demo: runbook pasa limpio de cero (compress 7d, gotcha activo, jobs panel robusto); PPT slide 10 alineada
</commit_message>
<xml_diff>
--- a/TimescaleDB-PPT-Javier.pptx
+++ b/TimescaleDB-PPT-Javier.pptx
@@ -3976,7 +3976,7 @@
                 </a:solidFill>
                 <a:latin typeface="Helvetica Neue"/>
               </a:rPr>
-              <a:t>       compress_after    =&gt; INTERVAL '24 hours',</a:t>
+              <a:t>       compress_after    =&gt; INTERVAL '7 days',</a:t>
             </a:r>
           </a:p>
           <a:p>
@@ -4140,7 +4140,7 @@
                 </a:solidFill>
                 <a:latin typeface="Helvetica Neue"/>
               </a:rPr>
-              <a:t>·  Cada </a:t>
+              <a:t>·  El job corre cada </a:t>
             </a:r>
             <a:r>
               <a:rPr b="1">
@@ -4158,7 +4158,7 @@
                 </a:solidFill>
                 <a:latin typeface="Helvetica Neue"/>
               </a:rPr>
-              <a:t> comprime/recomprime todo chunk cuyo rango terminó hace </a:t>
+              <a:t> y comprime todo chunk cuyo rango terminó hace </a:t>
             </a:r>
             <a:r>
               <a:rPr b="1">
@@ -4167,7 +4167,7 @@
                 </a:solidFill>
                 <a:latin typeface="Helvetica Neue"/>
               </a:rPr>
-              <a:t>&gt;24 h</a:t>
+              <a:t>&gt;7 días</a:t>
             </a:r>
             <a:r>
               <a:rPr>
@@ -4253,16 +4253,34 @@
                 </a:solidFill>
                 <a:latin typeface="Helvetica Neue"/>
               </a:rPr>
-              <a:t>Respeta el chunk activo</a:t>
-            </a:r>
-            <a:r>
-              <a:rPr>
-                <a:solidFill>
-                  <a:srgbClr val="1F2937"/>
-                </a:solidFill>
-                <a:latin typeface="Helvetica Neue"/>
-              </a:rPr>
-              <a:t>: nunca toca la ventana reciente (por eso el chunk de control sigue sin comprimir).</a:t>
+              <a:t>Respeta la ventana reciente</a:t>
+            </a:r>
+            <a:r>
+              <a:rPr>
+                <a:solidFill>
+                  <a:srgbClr val="1F2937"/>
+                </a:solidFill>
+                <a:latin typeface="Helvetica Neue"/>
+              </a:rPr>
+              <a:t>: con </a:t>
+            </a:r>
+            <a:r>
+              <a:rPr sz="1500" b="1">
+                <a:solidFill>
+                  <a:srgbClr val="0E7490"/>
+                </a:solidFill>
+                <a:latin typeface="Helvetica Neue"/>
+              </a:rPr>
+              <a:t>compress_after</a:t>
+            </a:r>
+            <a:r>
+              <a:rPr>
+                <a:solidFill>
+                  <a:srgbClr val="1F2937"/>
+                </a:solidFill>
+                <a:latin typeface="Helvetica Neue"/>
+              </a:rPr>
+              <a:t> amplio, el chunk de control sigue sin comprimir el día de la demo.</a:t>
             </a:r>
           </a:p>
           <a:p>

</xml_diff>

<commit_message>
PPT: ajustar la bio de la portada (Javier Aragon - Arquitecto IT, proyectos de aqui de alla)
</commit_message>
<xml_diff>
--- a/TimescaleDB-PPT-Javier.pptx
+++ b/TimescaleDB-PPT-Javier.pptx
@@ -15031,7 +15031,7 @@
                 </a:solidFill>
                 <a:latin typeface="Helvetica Neue"/>
               </a:rPr>
-              <a:t> — arquitecto IT.</a:t>
+              <a:t> - Arquitecto IT.</a:t>
             </a:r>
           </a:p>
           <a:p>
@@ -15099,7 +15099,7 @@
                 </a:solidFill>
                 <a:latin typeface="Helvetica Neue"/>
               </a:rPr>
-              <a:t>, en proyectos internacionales.</a:t>
+              <a:t> en proyectos de aquí de allá.</a:t>
             </a:r>
           </a:p>
           <a:p>
@@ -15124,7 +15124,7 @@
                 </a:solidFill>
                 <a:latin typeface="Helvetica Neue"/>
               </a:rPr>
-              <a:t>Y cada vez me siento más junior.</a:t>
+              <a:t>Y cada año, aunque no lo parezca, me siento más junior.</a:t>
             </a:r>
           </a:p>
         </p:txBody>

</xml_diff>